<commit_message>
deleted a slide in the pptx
</commit_message>
<xml_diff>
--- a/statistics/statistics conclusions.pptx
+++ b/statistics/statistics conclusions.pptx
@@ -8,10 +8,9 @@
     <p:sldId id="256" r:id="rId2"/>
     <p:sldId id="262" r:id="rId3"/>
     <p:sldId id="257" r:id="rId4"/>
-    <p:sldId id="261" r:id="rId5"/>
-    <p:sldId id="258" r:id="rId6"/>
-    <p:sldId id="259" r:id="rId7"/>
-    <p:sldId id="260" r:id="rId8"/>
+    <p:sldId id="258" r:id="rId5"/>
+    <p:sldId id="259" r:id="rId6"/>
+    <p:sldId id="260" r:id="rId7"/>
   </p:sldIdLst>
   <p:sldSz cx="12192000" cy="6858000"/>
   <p:notesSz cx="6858000" cy="9144000"/>
@@ -265,7 +264,7 @@
           <a:p>
             <a:fld id="{8510F7D5-8CA1-4183-AAB7-9CF1CE1D8590}" type="datetimeFigureOut">
               <a:rPr lang="en-US" smtClean="0"/>
-              <a:t>11/21/2023</a:t>
+              <a:t>11/27/2023</a:t>
             </a:fld>
             <a:endParaRPr lang="en-US"/>
           </a:p>
@@ -463,7 +462,7 @@
           <a:p>
             <a:fld id="{8510F7D5-8CA1-4183-AAB7-9CF1CE1D8590}" type="datetimeFigureOut">
               <a:rPr lang="en-US" smtClean="0"/>
-              <a:t>11/21/2023</a:t>
+              <a:t>11/27/2023</a:t>
             </a:fld>
             <a:endParaRPr lang="en-US"/>
           </a:p>
@@ -671,7 +670,7 @@
           <a:p>
             <a:fld id="{8510F7D5-8CA1-4183-AAB7-9CF1CE1D8590}" type="datetimeFigureOut">
               <a:rPr lang="en-US" smtClean="0"/>
-              <a:t>11/21/2023</a:t>
+              <a:t>11/27/2023</a:t>
             </a:fld>
             <a:endParaRPr lang="en-US"/>
           </a:p>
@@ -869,7 +868,7 @@
           <a:p>
             <a:fld id="{8510F7D5-8CA1-4183-AAB7-9CF1CE1D8590}" type="datetimeFigureOut">
               <a:rPr lang="en-US" smtClean="0"/>
-              <a:t>11/21/2023</a:t>
+              <a:t>11/27/2023</a:t>
             </a:fld>
             <a:endParaRPr lang="en-US"/>
           </a:p>
@@ -1144,7 +1143,7 @@
           <a:p>
             <a:fld id="{8510F7D5-8CA1-4183-AAB7-9CF1CE1D8590}" type="datetimeFigureOut">
               <a:rPr lang="en-US" smtClean="0"/>
-              <a:t>11/21/2023</a:t>
+              <a:t>11/27/2023</a:t>
             </a:fld>
             <a:endParaRPr lang="en-US"/>
           </a:p>
@@ -1409,7 +1408,7 @@
           <a:p>
             <a:fld id="{8510F7D5-8CA1-4183-AAB7-9CF1CE1D8590}" type="datetimeFigureOut">
               <a:rPr lang="en-US" smtClean="0"/>
-              <a:t>11/21/2023</a:t>
+              <a:t>11/27/2023</a:t>
             </a:fld>
             <a:endParaRPr lang="en-US"/>
           </a:p>
@@ -1821,7 +1820,7 @@
           <a:p>
             <a:fld id="{8510F7D5-8CA1-4183-AAB7-9CF1CE1D8590}" type="datetimeFigureOut">
               <a:rPr lang="en-US" smtClean="0"/>
-              <a:t>11/21/2023</a:t>
+              <a:t>11/27/2023</a:t>
             </a:fld>
             <a:endParaRPr lang="en-US"/>
           </a:p>
@@ -1962,7 +1961,7 @@
           <a:p>
             <a:fld id="{8510F7D5-8CA1-4183-AAB7-9CF1CE1D8590}" type="datetimeFigureOut">
               <a:rPr lang="en-US" smtClean="0"/>
-              <a:t>11/21/2023</a:t>
+              <a:t>11/27/2023</a:t>
             </a:fld>
             <a:endParaRPr lang="en-US"/>
           </a:p>
@@ -2075,7 +2074,7 @@
           <a:p>
             <a:fld id="{8510F7D5-8CA1-4183-AAB7-9CF1CE1D8590}" type="datetimeFigureOut">
               <a:rPr lang="en-US" smtClean="0"/>
-              <a:t>11/21/2023</a:t>
+              <a:t>11/27/2023</a:t>
             </a:fld>
             <a:endParaRPr lang="en-US"/>
           </a:p>
@@ -2386,7 +2385,7 @@
           <a:p>
             <a:fld id="{8510F7D5-8CA1-4183-AAB7-9CF1CE1D8590}" type="datetimeFigureOut">
               <a:rPr lang="en-US" smtClean="0"/>
-              <a:t>11/21/2023</a:t>
+              <a:t>11/27/2023</a:t>
             </a:fld>
             <a:endParaRPr lang="en-US"/>
           </a:p>
@@ -2674,7 +2673,7 @@
           <a:p>
             <a:fld id="{8510F7D5-8CA1-4183-AAB7-9CF1CE1D8590}" type="datetimeFigureOut">
               <a:rPr lang="en-US" smtClean="0"/>
-              <a:t>11/21/2023</a:t>
+              <a:t>11/27/2023</a:t>
             </a:fld>
             <a:endParaRPr lang="en-US"/>
           </a:p>
@@ -2915,7 +2914,7 @@
           <a:p>
             <a:fld id="{8510F7D5-8CA1-4183-AAB7-9CF1CE1D8590}" type="datetimeFigureOut">
               <a:rPr lang="en-US" smtClean="0"/>
-              <a:t>11/21/2023</a:t>
+              <a:t>11/27/2023</a:t>
             </a:fld>
             <a:endParaRPr lang="en-US"/>
           </a:p>
@@ -4249,477 +4248,6 @@
 </file>
 
 <file path=ppt/slides/slide4.xml><?xml version="1.0" encoding="utf-8"?>
-<p:sld xmlns:a="http://schemas.openxmlformats.org/drawingml/2006/main" xmlns:r="http://schemas.openxmlformats.org/officeDocument/2006/relationships" xmlns:p="http://schemas.openxmlformats.org/presentationml/2006/main">
-  <p:cSld>
-    <p:bg>
-      <p:bgPr>
-        <a:solidFill>
-          <a:schemeClr val="bg1"/>
-        </a:solidFill>
-        <a:effectLst/>
-      </p:bgPr>
-    </p:bg>
-    <p:spTree>
-      <p:nvGrpSpPr>
-        <p:cNvPr id="1" name=""/>
-        <p:cNvGrpSpPr/>
-        <p:nvPr/>
-      </p:nvGrpSpPr>
-      <p:grpSpPr>
-        <a:xfrm>
-          <a:off x="0" y="0"/>
-          <a:ext cx="0" cy="0"/>
-          <a:chOff x="0" y="0"/>
-          <a:chExt cx="0" cy="0"/>
-        </a:xfrm>
-      </p:grpSpPr>
-      <p:sp useBgFill="1">
-        <p:nvSpPr>
-          <p:cNvPr id="17" name="Rectangle 16">
-            <a:extLst>
-              <a:ext uri="{FF2B5EF4-FFF2-40B4-BE49-F238E27FC236}">
-                <a16:creationId xmlns:a16="http://schemas.microsoft.com/office/drawing/2014/main" id="{2B97F24A-32CE-4C1C-A50D-3016B394DCFB}"/>
-              </a:ext>
-              <a:ext uri="{C183D7F6-B498-43B3-948B-1728B52AA6E4}">
-                <adec:decorative xmlns:adec="http://schemas.microsoft.com/office/drawing/2017/decorative" val="1"/>
-              </a:ext>
-            </a:extLst>
-          </p:cNvPr>
-          <p:cNvSpPr>
-            <a:spLocks noGrp="1" noRot="1" noChangeAspect="1" noMove="1" noResize="1" noEditPoints="1" noAdjustHandles="1" noChangeArrowheads="1" noChangeShapeType="1" noTextEdit="1"/>
-          </p:cNvSpPr>
-          <p:nvPr>
-            <p:extLst>
-              <p:ext uri="{386F3935-93C4-4BCD-93E2-E3B085C9AB24}">
-                <p16:designElem xmlns:p16="http://schemas.microsoft.com/office/powerpoint/2015/main" val="1"/>
-              </p:ext>
-            </p:extLst>
-          </p:nvPr>
-        </p:nvSpPr>
-        <p:spPr>
-          <a:xfrm>
-            <a:off x="0" y="0"/>
-            <a:ext cx="12192000" cy="6858000"/>
-          </a:xfrm>
-          <a:prstGeom prst="rect">
-            <a:avLst/>
-          </a:prstGeom>
-          <a:ln>
-            <a:noFill/>
-          </a:ln>
-        </p:spPr>
-        <p:style>
-          <a:lnRef idx="2">
-            <a:schemeClr val="accent1">
-              <a:shade val="50000"/>
-            </a:schemeClr>
-          </a:lnRef>
-          <a:fillRef idx="1">
-            <a:schemeClr val="accent1"/>
-          </a:fillRef>
-          <a:effectRef idx="0">
-            <a:schemeClr val="accent1"/>
-          </a:effectRef>
-          <a:fontRef idx="minor">
-            <a:schemeClr val="lt1"/>
-          </a:fontRef>
-        </p:style>
-        <p:txBody>
-          <a:bodyPr rtlCol="0" anchor="ctr"/>
-          <a:lstStyle/>
-          <a:p>
-            <a:pPr algn="ctr"/>
-            <a:endParaRPr lang="en-US"/>
-          </a:p>
-        </p:txBody>
-      </p:sp>
-      <p:sp>
-        <p:nvSpPr>
-          <p:cNvPr id="2" name="Title 1">
-            <a:extLst>
-              <a:ext uri="{FF2B5EF4-FFF2-40B4-BE49-F238E27FC236}">
-                <a16:creationId xmlns:a16="http://schemas.microsoft.com/office/drawing/2014/main" id="{83190E84-1F12-E20E-DFA8-9561053EAB56}"/>
-              </a:ext>
-            </a:extLst>
-          </p:cNvPr>
-          <p:cNvSpPr>
-            <a:spLocks noGrp="1"/>
-          </p:cNvSpPr>
-          <p:nvPr>
-            <p:ph type="title"/>
-          </p:nvPr>
-        </p:nvSpPr>
-        <p:spPr>
-          <a:xfrm>
-            <a:off x="630936" y="639520"/>
-            <a:ext cx="3429000" cy="1719072"/>
-          </a:xfrm>
-        </p:spPr>
-        <p:txBody>
-          <a:bodyPr anchor="b">
-            <a:normAutofit/>
-          </a:bodyPr>
-          <a:lstStyle/>
-          <a:p>
-            <a:r>
-              <a:rPr lang="en-US" sz="5400"/>
-              <a:t>Feature histogram</a:t>
-            </a:r>
-          </a:p>
-        </p:txBody>
-      </p:sp>
-      <p:sp>
-        <p:nvSpPr>
-          <p:cNvPr id="19" name="sketch line">
-            <a:extLst>
-              <a:ext uri="{FF2B5EF4-FFF2-40B4-BE49-F238E27FC236}">
-                <a16:creationId xmlns:a16="http://schemas.microsoft.com/office/drawing/2014/main" id="{CD8B4F24-440B-49E9-B85D-733523DC064B}"/>
-              </a:ext>
-              <a:ext uri="{C183D7F6-B498-43B3-948B-1728B52AA6E4}">
-                <adec:decorative xmlns:adec="http://schemas.microsoft.com/office/drawing/2017/decorative" val="1"/>
-              </a:ext>
-            </a:extLst>
-          </p:cNvPr>
-          <p:cNvSpPr>
-            <a:spLocks noGrp="1" noRot="1" noChangeAspect="1" noMove="1" noResize="1" noEditPoints="1" noAdjustHandles="1" noChangeArrowheads="1" noChangeShapeType="1" noTextEdit="1"/>
-          </p:cNvSpPr>
-          <p:nvPr>
-            <p:extLst>
-              <p:ext uri="{386F3935-93C4-4BCD-93E2-E3B085C9AB24}">
-                <p16:designElem xmlns:p16="http://schemas.microsoft.com/office/powerpoint/2015/main" val="1"/>
-              </p:ext>
-            </p:extLst>
-          </p:nvPr>
-        </p:nvSpPr>
-        <p:spPr>
-          <a:xfrm>
-            <a:off x="643278" y="2573756"/>
-            <a:ext cx="3255095" cy="18288"/>
-          </a:xfrm>
-          <a:custGeom>
-            <a:avLst/>
-            <a:gdLst>
-              <a:gd name="connsiteX0" fmla="*/ 0 w 3255095"/>
-              <a:gd name="connsiteY0" fmla="*/ 0 h 18288"/>
-              <a:gd name="connsiteX1" fmla="*/ 618468 w 3255095"/>
-              <a:gd name="connsiteY1" fmla="*/ 0 h 18288"/>
-              <a:gd name="connsiteX2" fmla="*/ 1269487 w 3255095"/>
-              <a:gd name="connsiteY2" fmla="*/ 0 h 18288"/>
-              <a:gd name="connsiteX3" fmla="*/ 1953057 w 3255095"/>
-              <a:gd name="connsiteY3" fmla="*/ 0 h 18288"/>
-              <a:gd name="connsiteX4" fmla="*/ 2636627 w 3255095"/>
-              <a:gd name="connsiteY4" fmla="*/ 0 h 18288"/>
-              <a:gd name="connsiteX5" fmla="*/ 3255095 w 3255095"/>
-              <a:gd name="connsiteY5" fmla="*/ 0 h 18288"/>
-              <a:gd name="connsiteX6" fmla="*/ 3255095 w 3255095"/>
-              <a:gd name="connsiteY6" fmla="*/ 18288 h 18288"/>
-              <a:gd name="connsiteX7" fmla="*/ 2538974 w 3255095"/>
-              <a:gd name="connsiteY7" fmla="*/ 18288 h 18288"/>
-              <a:gd name="connsiteX8" fmla="*/ 1822853 w 3255095"/>
-              <a:gd name="connsiteY8" fmla="*/ 18288 h 18288"/>
-              <a:gd name="connsiteX9" fmla="*/ 1171834 w 3255095"/>
-              <a:gd name="connsiteY9" fmla="*/ 18288 h 18288"/>
-              <a:gd name="connsiteX10" fmla="*/ 0 w 3255095"/>
-              <a:gd name="connsiteY10" fmla="*/ 18288 h 18288"/>
-              <a:gd name="connsiteX11" fmla="*/ 0 w 3255095"/>
-              <a:gd name="connsiteY11" fmla="*/ 0 h 18288"/>
-            </a:gdLst>
-            <a:ahLst/>
-            <a:cxnLst>
-              <a:cxn ang="0">
-                <a:pos x="connsiteX0" y="connsiteY0"/>
-              </a:cxn>
-              <a:cxn ang="0">
-                <a:pos x="connsiteX1" y="connsiteY1"/>
-              </a:cxn>
-              <a:cxn ang="0">
-                <a:pos x="connsiteX2" y="connsiteY2"/>
-              </a:cxn>
-              <a:cxn ang="0">
-                <a:pos x="connsiteX3" y="connsiteY3"/>
-              </a:cxn>
-              <a:cxn ang="0">
-                <a:pos x="connsiteX4" y="connsiteY4"/>
-              </a:cxn>
-              <a:cxn ang="0">
-                <a:pos x="connsiteX5" y="connsiteY5"/>
-              </a:cxn>
-              <a:cxn ang="0">
-                <a:pos x="connsiteX6" y="connsiteY6"/>
-              </a:cxn>
-              <a:cxn ang="0">
-                <a:pos x="connsiteX7" y="connsiteY7"/>
-              </a:cxn>
-              <a:cxn ang="0">
-                <a:pos x="connsiteX8" y="connsiteY8"/>
-              </a:cxn>
-              <a:cxn ang="0">
-                <a:pos x="connsiteX9" y="connsiteY9"/>
-              </a:cxn>
-              <a:cxn ang="0">
-                <a:pos x="connsiteX10" y="connsiteY10"/>
-              </a:cxn>
-              <a:cxn ang="0">
-                <a:pos x="connsiteX11" y="connsiteY11"/>
-              </a:cxn>
-            </a:cxnLst>
-            <a:rect l="l" t="t" r="r" b="b"/>
-            <a:pathLst>
-              <a:path w="3255095" h="18288" fill="none" extrusionOk="0">
-                <a:moveTo>
-                  <a:pt x="0" y="0"/>
-                </a:moveTo>
-                <a:cubicBezTo>
-                  <a:pt x="240201" y="-22123"/>
-                  <a:pt x="462021" y="-19623"/>
-                  <a:pt x="618468" y="0"/>
-                </a:cubicBezTo>
-                <a:cubicBezTo>
-                  <a:pt x="774915" y="19623"/>
-                  <a:pt x="974734" y="2035"/>
-                  <a:pt x="1269487" y="0"/>
-                </a:cubicBezTo>
-                <a:cubicBezTo>
-                  <a:pt x="1564240" y="-2035"/>
-                  <a:pt x="1733579" y="10639"/>
-                  <a:pt x="1953057" y="0"/>
-                </a:cubicBezTo>
-                <a:cubicBezTo>
-                  <a:pt x="2172535" y="-10639"/>
-                  <a:pt x="2453962" y="14018"/>
-                  <a:pt x="2636627" y="0"/>
-                </a:cubicBezTo>
-                <a:cubicBezTo>
-                  <a:pt x="2819292" y="-14018"/>
-                  <a:pt x="3121375" y="5399"/>
-                  <a:pt x="3255095" y="0"/>
-                </a:cubicBezTo>
-                <a:cubicBezTo>
-                  <a:pt x="3254386" y="8157"/>
-                  <a:pt x="3254682" y="12125"/>
-                  <a:pt x="3255095" y="18288"/>
-                </a:cubicBezTo>
-                <a:cubicBezTo>
-                  <a:pt x="3088545" y="23203"/>
-                  <a:pt x="2687475" y="7419"/>
-                  <a:pt x="2538974" y="18288"/>
-                </a:cubicBezTo>
-                <a:cubicBezTo>
-                  <a:pt x="2390473" y="29157"/>
-                  <a:pt x="2137381" y="-8959"/>
-                  <a:pt x="1822853" y="18288"/>
-                </a:cubicBezTo>
-                <a:cubicBezTo>
-                  <a:pt x="1508325" y="45535"/>
-                  <a:pt x="1466437" y="20385"/>
-                  <a:pt x="1171834" y="18288"/>
-                </a:cubicBezTo>
-                <a:cubicBezTo>
-                  <a:pt x="877231" y="16191"/>
-                  <a:pt x="561097" y="37643"/>
-                  <a:pt x="0" y="18288"/>
-                </a:cubicBezTo>
-                <a:cubicBezTo>
-                  <a:pt x="-46" y="12483"/>
-                  <a:pt x="-203" y="6491"/>
-                  <a:pt x="0" y="0"/>
-                </a:cubicBezTo>
-                <a:close/>
-              </a:path>
-              <a:path w="3255095" h="18288" stroke="0" extrusionOk="0">
-                <a:moveTo>
-                  <a:pt x="0" y="0"/>
-                </a:moveTo>
-                <a:cubicBezTo>
-                  <a:pt x="291965" y="19429"/>
-                  <a:pt x="363155" y="8568"/>
-                  <a:pt x="618468" y="0"/>
-                </a:cubicBezTo>
-                <a:cubicBezTo>
-                  <a:pt x="873781" y="-8568"/>
-                  <a:pt x="904459" y="-19505"/>
-                  <a:pt x="1171834" y="0"/>
-                </a:cubicBezTo>
-                <a:cubicBezTo>
-                  <a:pt x="1439209" y="19505"/>
-                  <a:pt x="1744369" y="9790"/>
-                  <a:pt x="1887955" y="0"/>
-                </a:cubicBezTo>
-                <a:cubicBezTo>
-                  <a:pt x="2031541" y="-9790"/>
-                  <a:pt x="2346378" y="21240"/>
-                  <a:pt x="2506423" y="0"/>
-                </a:cubicBezTo>
-                <a:cubicBezTo>
-                  <a:pt x="2666468" y="-21240"/>
-                  <a:pt x="2990257" y="30414"/>
-                  <a:pt x="3255095" y="0"/>
-                </a:cubicBezTo>
-                <a:cubicBezTo>
-                  <a:pt x="3254831" y="4493"/>
-                  <a:pt x="3255479" y="9472"/>
-                  <a:pt x="3255095" y="18288"/>
-                </a:cubicBezTo>
-                <a:cubicBezTo>
-                  <a:pt x="3120743" y="16690"/>
-                  <a:pt x="2759628" y="42462"/>
-                  <a:pt x="2604076" y="18288"/>
-                </a:cubicBezTo>
-                <a:cubicBezTo>
-                  <a:pt x="2448524" y="-5886"/>
-                  <a:pt x="2184336" y="19599"/>
-                  <a:pt x="1887955" y="18288"/>
-                </a:cubicBezTo>
-                <a:cubicBezTo>
-                  <a:pt x="1591574" y="16977"/>
-                  <a:pt x="1548845" y="6870"/>
-                  <a:pt x="1334589" y="18288"/>
-                </a:cubicBezTo>
-                <a:cubicBezTo>
-                  <a:pt x="1120333" y="29706"/>
-                  <a:pt x="996014" y="9662"/>
-                  <a:pt x="683570" y="18288"/>
-                </a:cubicBezTo>
-                <a:cubicBezTo>
-                  <a:pt x="371126" y="26914"/>
-                  <a:pt x="198687" y="16167"/>
-                  <a:pt x="0" y="18288"/>
-                </a:cubicBezTo>
-                <a:cubicBezTo>
-                  <a:pt x="843" y="9577"/>
-                  <a:pt x="371" y="6900"/>
-                  <a:pt x="0" y="0"/>
-                </a:cubicBezTo>
-                <a:close/>
-              </a:path>
-            </a:pathLst>
-          </a:custGeom>
-          <a:solidFill>
-            <a:schemeClr val="accent2"/>
-          </a:solidFill>
-          <a:ln w="38100" cap="rnd">
-            <a:solidFill>
-              <a:schemeClr val="accent2"/>
-            </a:solidFill>
-            <a:round/>
-            <a:extLst>
-              <a:ext uri="{C807C97D-BFC1-408E-A445-0C87EB9F89A2}">
-                <ask:lineSketchStyleProps xmlns:ask="http://schemas.microsoft.com/office/drawing/2018/sketchyshapes" sd="1219033472">
-                  <a:prstGeom prst="rect">
-                    <a:avLst/>
-                  </a:prstGeom>
-                  <ask:type>
-                    <ask:lineSketchFreehand/>
-                  </ask:type>
-                </ask:lineSketchStyleProps>
-              </a:ext>
-            </a:extLst>
-          </a:ln>
-        </p:spPr>
-        <p:style>
-          <a:lnRef idx="2">
-            <a:schemeClr val="accent1">
-              <a:shade val="50000"/>
-            </a:schemeClr>
-          </a:lnRef>
-          <a:fillRef idx="1">
-            <a:schemeClr val="accent1"/>
-          </a:fillRef>
-          <a:effectRef idx="0">
-            <a:schemeClr val="accent1"/>
-          </a:effectRef>
-          <a:fontRef idx="minor">
-            <a:schemeClr val="lt1"/>
-          </a:fontRef>
-        </p:style>
-        <p:txBody>
-          <a:bodyPr rtlCol="0" anchor="ctr"/>
-          <a:lstStyle/>
-          <a:p>
-            <a:pPr algn="ctr"/>
-            <a:endParaRPr lang="en-US"/>
-          </a:p>
-        </p:txBody>
-      </p:sp>
-      <p:sp>
-        <p:nvSpPr>
-          <p:cNvPr id="3" name="Content Placeholder 2">
-            <a:extLst>
-              <a:ext uri="{FF2B5EF4-FFF2-40B4-BE49-F238E27FC236}">
-                <a16:creationId xmlns:a16="http://schemas.microsoft.com/office/drawing/2014/main" id="{3F225963-A298-CB74-AB96-416776BF220C}"/>
-              </a:ext>
-            </a:extLst>
-          </p:cNvPr>
-          <p:cNvSpPr>
-            <a:spLocks noGrp="1"/>
-          </p:cNvSpPr>
-          <p:nvPr>
-            <p:ph idx="1"/>
-          </p:nvPr>
-        </p:nvSpPr>
-        <p:spPr>
-          <a:xfrm>
-            <a:off x="630936" y="2807208"/>
-            <a:ext cx="3429000" cy="3410712"/>
-          </a:xfrm>
-        </p:spPr>
-        <p:txBody>
-          <a:bodyPr anchor="t">
-            <a:normAutofit/>
-          </a:bodyPr>
-          <a:lstStyle/>
-          <a:p>
-            <a:endParaRPr lang="en-US" sz="2200"/>
-          </a:p>
-          <a:p>
-            <a:endParaRPr lang="en-US" sz="2200"/>
-          </a:p>
-        </p:txBody>
-      </p:sp>
-      <p:pic>
-        <p:nvPicPr>
-          <p:cNvPr id="5" name="Picture 4" descr="A screenshot of a graph&#10;&#10;Description automatically generated">
-            <a:extLst>
-              <a:ext uri="{FF2B5EF4-FFF2-40B4-BE49-F238E27FC236}">
-                <a16:creationId xmlns:a16="http://schemas.microsoft.com/office/drawing/2014/main" id="{8E9FDA9A-1B96-9ABD-38A4-4BAEBFAE97E5}"/>
-              </a:ext>
-            </a:extLst>
-          </p:cNvPr>
-          <p:cNvPicPr>
-            <a:picLocks noChangeAspect="1"/>
-          </p:cNvPicPr>
-          <p:nvPr/>
-        </p:nvPicPr>
-        <p:blipFill>
-          <a:blip r:embed="rId2"/>
-          <a:stretch>
-            <a:fillRect/>
-          </a:stretch>
-        </p:blipFill>
-        <p:spPr>
-          <a:xfrm>
-            <a:off x="4654296" y="1437542"/>
-            <a:ext cx="6903720" cy="3982915"/>
-          </a:xfrm>
-          <a:prstGeom prst="rect">
-            <a:avLst/>
-          </a:prstGeom>
-        </p:spPr>
-      </p:pic>
-    </p:spTree>
-    <p:extLst>
-      <p:ext uri="{BB962C8B-B14F-4D97-AF65-F5344CB8AC3E}">
-        <p14:creationId xmlns:p14="http://schemas.microsoft.com/office/powerpoint/2010/main" val="329662096"/>
-      </p:ext>
-    </p:extLst>
-  </p:cSld>
-  <p:clrMapOvr>
-    <a:masterClrMapping/>
-  </p:clrMapOvr>
-</p:sld>
-</file>
-
-<file path=ppt/slides/slide5.xml><?xml version="1.0" encoding="utf-8"?>
 <p:sld xmlns:a="http://schemas.openxmlformats.org/drawingml/2006/main" xmlns:r="http://schemas.openxmlformats.org/officeDocument/2006/relationships" xmlns:p="http://schemas.openxmlformats.org/presentationml/2006/main">
   <p:cSld>
     <p:bg>
@@ -5708,7 +5236,7 @@
 </p:sld>
 </file>
 
-<file path=ppt/slides/slide6.xml><?xml version="1.0" encoding="utf-8"?>
+<file path=ppt/slides/slide5.xml><?xml version="1.0" encoding="utf-8"?>
 <p:sld xmlns:a="http://schemas.openxmlformats.org/drawingml/2006/main" xmlns:r="http://schemas.openxmlformats.org/officeDocument/2006/relationships" xmlns:p="http://schemas.openxmlformats.org/presentationml/2006/main">
   <p:cSld>
     <p:bg>
@@ -6066,7 +5594,7 @@
 </p:sld>
 </file>
 
-<file path=ppt/slides/slide7.xml><?xml version="1.0" encoding="utf-8"?>
+<file path=ppt/slides/slide6.xml><?xml version="1.0" encoding="utf-8"?>
 <p:sld xmlns:a="http://schemas.openxmlformats.org/drawingml/2006/main" xmlns:r="http://schemas.openxmlformats.org/officeDocument/2006/relationships" xmlns:p="http://schemas.openxmlformats.org/presentationml/2006/main">
   <p:cSld>
     <p:bg>

</xml_diff>